<commit_message>
fix(templates): clear yellow artwork and preserve readable case studies
</commit_message>
<xml_diff>
--- a/templates/modern-yellow.pptx
+++ b/templates/modern-yellow.pptx
@@ -1610,7 +1610,7 @@
         </p:nvSpPr>
         <p:spPr>
           <a:xfrm>
-            <a:off x="0" y="1898247"/>
+            <a:off x="-1779706" y="1898247"/>
             <a:ext cx="2079706" cy="4140000"/>
           </a:xfrm>
           <a:custGeom>
@@ -1672,7 +1672,9 @@
             </a:pathLst>
           </a:custGeom>
           <a:solidFill>
-            <a:srgbClr val="FECE00"/>
+            <a:srgbClr val="FECE00">
+              <a:alpha val="24000"/>
+            </a:srgbClr>
           </a:solidFill>
           <a:ln w="57150">
             <a:noFill/>
@@ -1682,7 +1684,7 @@
               <a:schemeClr val="tx1">
                 <a:lumMod val="50000"/>
                 <a:lumOff val="50000"/>
-                <a:alpha val="26000"/>
+                <a:alpha val="8000"/>
               </a:schemeClr>
             </a:outerShdw>
           </a:effectLst>

</xml_diff>

<commit_message>
fix(template): quiet yellow Statement artwork
</commit_message>
<xml_diff>
--- a/templates/modern-yellow.pptx
+++ b/templates/modern-yellow.pptx
@@ -1085,7 +1085,7 @@
         </p:nvSpPr>
         <p:spPr>
           <a:xfrm>
-            <a:off x="0" y="0"/>
+            <a:off x="0" y="-1750154"/>
             <a:ext cx="12192000" cy="2110154"/>
           </a:xfrm>
           <a:custGeom>
@@ -1149,7 +1149,7 @@
               <a:schemeClr val="tx1">
                 <a:lumMod val="50000"/>
                 <a:lumOff val="50000"/>
-                <a:alpha val="26000"/>
+                <a:alpha val="8000"/>
               </a:schemeClr>
             </a:outerShdw>
           </a:effectLst>

</xml_diff>